<commit_message>
Fix PPT: remove school affiliation, update to Senior Solution Engineer
</commit_message>
<xml_diff>
--- a/AMA-终汇报-PPT.pptx
+++ b/AMA-终汇报-PPT.pptx
@@ -3102,290 +3102,8 @@
 </p:sldMaster>
 </file>
 
-<file path=ppt/slides/slide1.xml><?xml version="1.0" encoding="utf-8"?>
-<p:sld xmlns:a="http://schemas.openxmlformats.org/drawingml/2006/main" xmlns:p="http://schemas.openxmlformats.org/presentationml/2006/main" xmlns:r="http://schemas.openxmlformats.org/officeDocument/2006/relationships">
-  <p:cSld>
-    <p:bg>
-      <p:bgPr>
-        <a:solidFill>
-          <a:srgbClr val="002050"/>
-        </a:solidFill>
-        <a:effectLst/>
-      </p:bgPr>
-    </p:bg>
-    <p:spTree>
-      <p:nvGrpSpPr>
-        <p:cNvPr id="1" name=""/>
-        <p:cNvGrpSpPr/>
-        <p:nvPr/>
-      </p:nvGrpSpPr>
-      <p:grpSpPr/>
-      <p:sp>
-        <p:nvSpPr>
-          <p:cNvPr id="2" name="Rectangle 1"/>
-          <p:cNvSpPr/>
-          <p:nvPr/>
-        </p:nvSpPr>
-        <p:spPr>
-          <a:xfrm>
-            <a:off x="0" y="0"/>
-            <a:ext cx="12191695" cy="73152"/>
-          </a:xfrm>
-          <a:prstGeom prst="rect">
-            <a:avLst/>
-          </a:prstGeom>
-          <a:solidFill>
-            <a:srgbClr val="FFD700"/>
-          </a:solidFill>
-          <a:ln>
-            <a:noFill/>
-          </a:ln>
-        </p:spPr>
-        <p:style>
-          <a:lnRef idx="1">
-            <a:schemeClr val="accent1"/>
-          </a:lnRef>
-          <a:fillRef idx="3">
-            <a:schemeClr val="accent1"/>
-          </a:fillRef>
-          <a:effectRef idx="2">
-            <a:schemeClr val="accent1"/>
-          </a:effectRef>
-          <a:fontRef idx="minor">
-            <a:schemeClr val="lt1"/>
-          </a:fontRef>
-        </p:style>
-        <p:txBody>
-          <a:bodyPr rtlCol="0" anchor="ctr"/>
-          <a:lstStyle/>
-          <a:p>
-            <a:pPr algn="ctr"/>
-          </a:p>
-        </p:txBody>
-      </p:sp>
-      <p:sp>
-        <p:nvSpPr>
-          <p:cNvPr id="3" name="TextBox 2"/>
-          <p:cNvSpPr txBox="1"/>
-          <p:nvPr/>
-        </p:nvSpPr>
-        <p:spPr>
-          <a:xfrm>
-            <a:off x="914400" y="1645920"/>
-            <a:ext cx="10332720" cy="1097280"/>
-          </a:xfrm>
-          <a:prstGeom prst="rect">
-            <a:avLst/>
-          </a:prstGeom>
-          <a:noFill/>
-        </p:spPr>
-        <p:txBody>
-          <a:bodyPr wrap="square">
-            <a:spAutoFit/>
-          </a:bodyPr>
-          <a:lstStyle/>
-          <a:p>
-            <a:pPr algn="ctr">
-              <a:defRPr sz="4200" b="1">
-                <a:solidFill>
-                  <a:srgbClr val="FFFFFF"/>
-                </a:solidFill>
-                <a:latin typeface="Microsoft YaHei"/>
-              </a:defRPr>
-            </a:pPr>
-            <a:r>
-              <a:t>Autonomous Retail Intelligence</a:t>
-            </a:r>
-            <a:br/>
-            <a:r>
-              <a:t>Agent Platform</a:t>
-            </a:r>
-          </a:p>
-        </p:txBody>
-      </p:sp>
-      <p:sp>
-        <p:nvSpPr>
-          <p:cNvPr id="4" name="TextBox 3"/>
-          <p:cNvSpPr txBox="1"/>
-          <p:nvPr/>
-        </p:nvSpPr>
-        <p:spPr>
-          <a:xfrm>
-            <a:off x="914400" y="3017520"/>
-            <a:ext cx="10332720" cy="731520"/>
-          </a:xfrm>
-          <a:prstGeom prst="rect">
-            <a:avLst/>
-          </a:prstGeom>
-          <a:noFill/>
-        </p:spPr>
-        <p:txBody>
-          <a:bodyPr wrap="square">
-            <a:spAutoFit/>
-          </a:bodyPr>
-          <a:lstStyle/>
-          <a:p>
-            <a:pPr algn="ctr">
-              <a:defRPr sz="2400" b="0">
-                <a:solidFill>
-                  <a:srgbClr val="FFD700"/>
-                </a:solidFill>
-                <a:latin typeface="Microsoft YaHei"/>
-              </a:defRPr>
-            </a:pPr>
-            <a:r>
-              <a:t>基于优衣库的多 Agent 智能零售平台</a:t>
-            </a:r>
-          </a:p>
-        </p:txBody>
-      </p:sp>
-      <p:sp>
-        <p:nvSpPr>
-          <p:cNvPr id="5" name="Rectangle 4"/>
-          <p:cNvSpPr/>
-          <p:nvPr/>
-        </p:nvSpPr>
-        <p:spPr>
-          <a:xfrm>
-            <a:off x="4572000" y="3931920"/>
-            <a:ext cx="3017520" cy="36576"/>
-          </a:xfrm>
-          <a:prstGeom prst="rect">
-            <a:avLst/>
-          </a:prstGeom>
-          <a:solidFill>
-            <a:srgbClr val="FFD700"/>
-          </a:solidFill>
-          <a:ln>
-            <a:noFill/>
-          </a:ln>
-        </p:spPr>
-        <p:style>
-          <a:lnRef idx="1">
-            <a:schemeClr val="accent1"/>
-          </a:lnRef>
-          <a:fillRef idx="3">
-            <a:schemeClr val="accent1"/>
-          </a:fillRef>
-          <a:effectRef idx="2">
-            <a:schemeClr val="accent1"/>
-          </a:effectRef>
-          <a:fontRef idx="minor">
-            <a:schemeClr val="lt1"/>
-          </a:fontRef>
-        </p:style>
-        <p:txBody>
-          <a:bodyPr rtlCol="0" anchor="ctr"/>
-          <a:lstStyle/>
-          <a:p>
-            <a:pPr algn="ctr"/>
-          </a:p>
-        </p:txBody>
-      </p:sp>
-      <p:sp>
-        <p:nvSpPr>
-          <p:cNvPr id="6" name="TextBox 5"/>
-          <p:cNvSpPr txBox="1"/>
-          <p:nvPr/>
-        </p:nvSpPr>
-        <p:spPr>
-          <a:xfrm>
-            <a:off x="914400" y="4389120"/>
-            <a:ext cx="10332720" cy="1371600"/>
-          </a:xfrm>
-          <a:prstGeom prst="rect">
-            <a:avLst/>
-          </a:prstGeom>
-          <a:noFill/>
-        </p:spPr>
-        <p:txBody>
-          <a:bodyPr wrap="square">
-            <a:spAutoFit/>
-          </a:bodyPr>
-          <a:lstStyle/>
-          <a:p>
-            <a:pPr algn="ctr">
-              <a:spcAft>
-                <a:spcPts val="720"/>
-              </a:spcAft>
-              <a:defRPr sz="1800" b="0">
-                <a:solidFill>
-                  <a:srgbClr val="CCCCCC"/>
-                </a:solidFill>
-                <a:latin typeface="Microsoft YaHei"/>
-              </a:defRPr>
-            </a:pPr>
-            <a:r>
-              <a:t>汇报人：圆子  MBA24级7班  |  科创青干营4期</a:t>
-            </a:r>
-          </a:p>
-          <a:p>
-            <a:pPr algn="ctr">
-              <a:spcAft>
-                <a:spcPts val="720"/>
-              </a:spcAft>
-              <a:defRPr sz="1800" b="0">
-                <a:solidFill>
-                  <a:srgbClr val="CCCCCC"/>
-                </a:solidFill>
-                <a:latin typeface="Microsoft YaHei"/>
-              </a:defRPr>
-            </a:pPr>
-            <a:r>
-              <a:t>AMA Capstone Project  |  Project 46</a:t>
-            </a:r>
-          </a:p>
-        </p:txBody>
-      </p:sp>
-      <p:sp>
-        <p:nvSpPr>
-          <p:cNvPr id="7" name="Rectangle 6"/>
-          <p:cNvSpPr/>
-          <p:nvPr/>
-        </p:nvSpPr>
-        <p:spPr>
-          <a:xfrm>
-            <a:off x="0" y="6784848"/>
-            <a:ext cx="12191695" cy="73152"/>
-          </a:xfrm>
-          <a:prstGeom prst="rect">
-            <a:avLst/>
-          </a:prstGeom>
-          <a:solidFill>
-            <a:srgbClr val="FFD700"/>
-          </a:solidFill>
-          <a:ln>
-            <a:noFill/>
-          </a:ln>
-        </p:spPr>
-        <p:style>
-          <a:lnRef idx="1">
-            <a:schemeClr val="accent1"/>
-          </a:lnRef>
-          <a:fillRef idx="3">
-            <a:schemeClr val="accent1"/>
-          </a:fillRef>
-          <a:effectRef idx="2">
-            <a:schemeClr val="accent1"/>
-          </a:effectRef>
-          <a:fontRef idx="minor">
-            <a:schemeClr val="lt1"/>
-          </a:fontRef>
-        </p:style>
-        <p:txBody>
-          <a:bodyPr rtlCol="0" anchor="ctr"/>
-          <a:lstStyle/>
-          <a:p>
-            <a:pPr algn="ctr"/>
-          </a:p>
-        </p:txBody>
-      </p:sp>
-    </p:spTree>
-  </p:cSld>
-  <p:clrMapOvr>
-    <a:masterClrMapping/>
-  </p:clrMapOvr>
-</p:sld>
+<file path=ppt/slides/slide1.xml><?xml version='1.0' encoding='UTF-8' standalone='yes'?>
+<p:sld xmlns:a="http://schemas.openxmlformats.org/drawingml/2006/main" xmlns:p="http://schemas.openxmlformats.org/presentationml/2006/main" xmlns:r="http://schemas.openxmlformats.org/officeDocument/2006/relationships"><p:cSld><p:bg><p:bgPr><a:solidFill><a:srgbClr val="002050"/></a:solidFill><a:effectLst/></p:bgPr></p:bg><p:spTree><p:nvGrpSpPr><p:cNvPr id="1" name=""/><p:cNvGrpSpPr/><p:nvPr/></p:nvGrpSpPr><p:grpSpPr/><p:sp><p:nvSpPr><p:cNvPr id="2" name="Rectangle 1"/><p:cNvSpPr/><p:nvPr/></p:nvSpPr><p:spPr><a:xfrm><a:off x="0" y="0"/><a:ext cx="12191695" cy="73152"/></a:xfrm><a:prstGeom prst="rect"><a:avLst/></a:prstGeom><a:solidFill><a:srgbClr val="FFD700"/></a:solidFill><a:ln><a:noFill/></a:ln></p:spPr><p:style><a:lnRef idx="1"><a:schemeClr val="accent1"/></a:lnRef><a:fillRef idx="3"><a:schemeClr val="accent1"/></a:fillRef><a:effectRef idx="2"><a:schemeClr val="accent1"/></a:effectRef><a:fontRef idx="minor"><a:schemeClr val="lt1"/></a:fontRef></p:style><p:txBody><a:bodyPr rtlCol="0" anchor="ctr"/><a:lstStyle/><a:p><a:pPr algn="ctr"/></a:p></p:txBody></p:sp><p:sp><p:nvSpPr><p:cNvPr id="3" name="TextBox 2"/><p:cNvSpPr txBox="1"/><p:nvPr/></p:nvSpPr><p:spPr><a:xfrm><a:off x="914400" y="1645920"/><a:ext cx="10332720" cy="1097280"/></a:xfrm><a:prstGeom prst="rect"><a:avLst/></a:prstGeom><a:noFill/></p:spPr><p:txBody><a:bodyPr wrap="square"><a:spAutoFit/></a:bodyPr><a:lstStyle/><a:p><a:pPr algn="ctr"><a:defRPr sz="4200" b="1"><a:solidFill><a:srgbClr val="FFFFFF"/></a:solidFill><a:latin typeface="Microsoft YaHei"/></a:defRPr></a:pPr><a:r><a:t>Autonomous Retail Intelligence</a:t></a:r><a:br/><a:r><a:t>Agent Platform</a:t></a:r></a:p></p:txBody></p:sp><p:sp><p:nvSpPr><p:cNvPr id="4" name="TextBox 3"/><p:cNvSpPr txBox="1"/><p:nvPr/></p:nvSpPr><p:spPr><a:xfrm><a:off x="914400" y="3017520"/><a:ext cx="10332720" cy="731520"/></a:xfrm><a:prstGeom prst="rect"><a:avLst/></a:prstGeom><a:noFill/></p:spPr><p:txBody><a:bodyPr wrap="square"><a:spAutoFit/></a:bodyPr><a:lstStyle/><a:p><a:pPr algn="ctr"><a:defRPr sz="2400" b="0"><a:solidFill><a:srgbClr val="FFD700"/></a:solidFill><a:latin typeface="Microsoft YaHei"/></a:defRPr></a:pPr><a:r><a:t>基于优衣库的多 Agent 智能零售平台</a:t></a:r></a:p></p:txBody></p:sp><p:sp><p:nvSpPr><p:cNvPr id="5" name="Rectangle 4"/><p:cNvSpPr/><p:nvPr/></p:nvSpPr><p:spPr><a:xfrm><a:off x="4572000" y="3931920"/><a:ext cx="3017520" cy="36576"/></a:xfrm><a:prstGeom prst="rect"><a:avLst/></a:prstGeom><a:solidFill><a:srgbClr val="FFD700"/></a:solidFill><a:ln><a:noFill/></a:ln></p:spPr><p:style><a:lnRef idx="1"><a:schemeClr val="accent1"/></a:lnRef><a:fillRef idx="3"><a:schemeClr val="accent1"/></a:fillRef><a:effectRef idx="2"><a:schemeClr val="accent1"/></a:effectRef><a:fontRef idx="minor"><a:schemeClr val="lt1"/></a:fontRef></p:style><p:txBody><a:bodyPr rtlCol="0" anchor="ctr"/><a:lstStyle/><a:p><a:pPr algn="ctr"/></a:p></p:txBody></p:sp><p:sp><p:nvSpPr><p:cNvPr id="6" name="TextBox 5"/><p:cNvSpPr txBox="1"/><p:nvPr/></p:nvSpPr><p:spPr><a:xfrm><a:off x="914400" y="4389120"/><a:ext cx="10332720" cy="1371600"/></a:xfrm><a:prstGeom prst="rect"><a:avLst/></a:prstGeom><a:noFill/></p:spPr><p:txBody><a:bodyPr wrap="square"><a:spAutoFit/></a:bodyPr><a:lstStyle/><a:p><a:pPr algn="ctr"><a:spcAft><a:spcPts val="720"/></a:spcAft><a:defRPr sz="1800" b="0"><a:solidFill><a:srgbClr val="CCCCCC"/></a:solidFill><a:latin typeface="Microsoft YaHei"/></a:defRPr></a:pPr><a:r><a:t>汇报人：圆子  Senior Solution Engineer, Azure & AI Platform</a:t></a:r></a:p><a:p><a:pPr algn="ctr"><a:spcAft><a:spcPts val="720"/></a:spcAft><a:defRPr sz="1800" b="0"><a:solidFill><a:srgbClr val="CCCCCC"/></a:solidFill><a:latin typeface="Microsoft YaHei"/></a:defRPr></a:pPr><a:r><a:t>AMA Capstone Project  |  Project 46</a:t></a:r></a:p></p:txBody></p:sp><p:sp><p:nvSpPr><p:cNvPr id="7" name="Rectangle 6"/><p:cNvSpPr/><p:nvPr/></p:nvSpPr><p:spPr><a:xfrm><a:off x="0" y="6784848"/><a:ext cx="12191695" cy="73152"/></a:xfrm><a:prstGeom prst="rect"><a:avLst/></a:prstGeom><a:solidFill><a:srgbClr val="FFD700"/></a:solidFill><a:ln><a:noFill/></a:ln></p:spPr><p:style><a:lnRef idx="1"><a:schemeClr val="accent1"/></a:lnRef><a:fillRef idx="3"><a:schemeClr val="accent1"/></a:fillRef><a:effectRef idx="2"><a:schemeClr val="accent1"/></a:effectRef><a:fontRef idx="minor"><a:schemeClr val="lt1"/></a:fontRef></p:style><p:txBody><a:bodyPr rtlCol="0" anchor="ctr"/><a:lstStyle/><a:p><a:pPr algn="ctr"/></a:p></p:txBody></p:sp></p:spTree></p:cSld><p:clrMapOvr><a:masterClrMapping/></p:clrMapOvr></p:sld>
 </file>
 
 <file path=ppt/slides/slide10.xml><?xml version="1.0" encoding="utf-8"?>
@@ -14449,315 +14167,8 @@
 </p:sld>
 </file>
 
-<file path=ppt/slides/slide25.xml><?xml version="1.0" encoding="utf-8"?>
-<p:sld xmlns:a="http://schemas.openxmlformats.org/drawingml/2006/main" xmlns:p="http://schemas.openxmlformats.org/presentationml/2006/main" xmlns:r="http://schemas.openxmlformats.org/officeDocument/2006/relationships">
-  <p:cSld>
-    <p:bg>
-      <p:bgPr>
-        <a:solidFill>
-          <a:srgbClr val="002050"/>
-        </a:solidFill>
-        <a:effectLst/>
-      </p:bgPr>
-    </p:bg>
-    <p:spTree>
-      <p:nvGrpSpPr>
-        <p:cNvPr id="1" name=""/>
-        <p:cNvGrpSpPr/>
-        <p:nvPr/>
-      </p:nvGrpSpPr>
-      <p:grpSpPr/>
-      <p:sp>
-        <p:nvSpPr>
-          <p:cNvPr id="2" name="Rectangle 1"/>
-          <p:cNvSpPr/>
-          <p:nvPr/>
-        </p:nvSpPr>
-        <p:spPr>
-          <a:xfrm>
-            <a:off x="0" y="0"/>
-            <a:ext cx="12191695" cy="73152"/>
-          </a:xfrm>
-          <a:prstGeom prst="rect">
-            <a:avLst/>
-          </a:prstGeom>
-          <a:solidFill>
-            <a:srgbClr val="FFD700"/>
-          </a:solidFill>
-          <a:ln>
-            <a:noFill/>
-          </a:ln>
-        </p:spPr>
-        <p:style>
-          <a:lnRef idx="1">
-            <a:schemeClr val="accent1"/>
-          </a:lnRef>
-          <a:fillRef idx="3">
-            <a:schemeClr val="accent1"/>
-          </a:fillRef>
-          <a:effectRef idx="2">
-            <a:schemeClr val="accent1"/>
-          </a:effectRef>
-          <a:fontRef idx="minor">
-            <a:schemeClr val="lt1"/>
-          </a:fontRef>
-        </p:style>
-        <p:txBody>
-          <a:bodyPr rtlCol="0" anchor="ctr"/>
-          <a:lstStyle/>
-          <a:p>
-            <a:pPr algn="ctr"/>
-          </a:p>
-        </p:txBody>
-      </p:sp>
-      <p:sp>
-        <p:nvSpPr>
-          <p:cNvPr id="3" name="TextBox 2"/>
-          <p:cNvSpPr txBox="1"/>
-          <p:nvPr/>
-        </p:nvSpPr>
-        <p:spPr>
-          <a:xfrm>
-            <a:off x="914400" y="1828800"/>
-            <a:ext cx="10332720" cy="1371600"/>
-          </a:xfrm>
-          <a:prstGeom prst="rect">
-            <a:avLst/>
-          </a:prstGeom>
-          <a:noFill/>
-        </p:spPr>
-        <p:txBody>
-          <a:bodyPr wrap="square">
-            <a:spAutoFit/>
-          </a:bodyPr>
-          <a:lstStyle/>
-          <a:p>
-            <a:pPr algn="ctr">
-              <a:defRPr sz="5200" b="1">
-                <a:solidFill>
-                  <a:srgbClr val="FFFFFF"/>
-                </a:solidFill>
-                <a:latin typeface="Microsoft YaHei"/>
-              </a:defRPr>
-            </a:pPr>
-            <a:r>
-              <a:t>Thank You</a:t>
-            </a:r>
-          </a:p>
-        </p:txBody>
-      </p:sp>
-      <p:sp>
-        <p:nvSpPr>
-          <p:cNvPr id="4" name="TextBox 3"/>
-          <p:cNvSpPr txBox="1"/>
-          <p:nvPr/>
-        </p:nvSpPr>
-        <p:spPr>
-          <a:xfrm>
-            <a:off x="914400" y="3200400"/>
-            <a:ext cx="10332720" cy="731520"/>
-          </a:xfrm>
-          <a:prstGeom prst="rect">
-            <a:avLst/>
-          </a:prstGeom>
-          <a:noFill/>
-        </p:spPr>
-        <p:txBody>
-          <a:bodyPr wrap="square">
-            <a:spAutoFit/>
-          </a:bodyPr>
-          <a:lstStyle/>
-          <a:p>
-            <a:pPr algn="ctr">
-              <a:defRPr sz="3200" b="0">
-                <a:solidFill>
-                  <a:srgbClr val="FFD700"/>
-                </a:solidFill>
-                <a:latin typeface="Microsoft YaHei"/>
-              </a:defRPr>
-            </a:pPr>
-            <a:r>
-              <a:t>谢谢</a:t>
-            </a:r>
-          </a:p>
-        </p:txBody>
-      </p:sp>
-      <p:sp>
-        <p:nvSpPr>
-          <p:cNvPr id="5" name="Rectangle 4"/>
-          <p:cNvSpPr/>
-          <p:nvPr/>
-        </p:nvSpPr>
-        <p:spPr>
-          <a:xfrm>
-            <a:off x="4572000" y="4114800"/>
-            <a:ext cx="3017520" cy="36576"/>
-          </a:xfrm>
-          <a:prstGeom prst="rect">
-            <a:avLst/>
-          </a:prstGeom>
-          <a:solidFill>
-            <a:srgbClr val="FFD700"/>
-          </a:solidFill>
-          <a:ln>
-            <a:noFill/>
-          </a:ln>
-        </p:spPr>
-        <p:style>
-          <a:lnRef idx="1">
-            <a:schemeClr val="accent1"/>
-          </a:lnRef>
-          <a:fillRef idx="3">
-            <a:schemeClr val="accent1"/>
-          </a:fillRef>
-          <a:effectRef idx="2">
-            <a:schemeClr val="accent1"/>
-          </a:effectRef>
-          <a:fontRef idx="minor">
-            <a:schemeClr val="lt1"/>
-          </a:fontRef>
-        </p:style>
-        <p:txBody>
-          <a:bodyPr rtlCol="0" anchor="ctr"/>
-          <a:lstStyle/>
-          <a:p>
-            <a:pPr algn="ctr"/>
-          </a:p>
-        </p:txBody>
-      </p:sp>
-      <p:sp>
-        <p:nvSpPr>
-          <p:cNvPr id="6" name="TextBox 5"/>
-          <p:cNvSpPr txBox="1"/>
-          <p:nvPr/>
-        </p:nvSpPr>
-        <p:spPr>
-          <a:xfrm>
-            <a:off x="914400" y="4572000"/>
-            <a:ext cx="10332720" cy="1371600"/>
-          </a:xfrm>
-          <a:prstGeom prst="rect">
-            <a:avLst/>
-          </a:prstGeom>
-          <a:noFill/>
-        </p:spPr>
-        <p:txBody>
-          <a:bodyPr wrap="square">
-            <a:spAutoFit/>
-          </a:bodyPr>
-          <a:lstStyle/>
-          <a:p>
-            <a:pPr algn="ctr">
-              <a:spcAft>
-                <a:spcPts val="720"/>
-              </a:spcAft>
-              <a:defRPr sz="1800" b="0">
-                <a:solidFill>
-                  <a:srgbClr val="CCCCCC"/>
-                </a:solidFill>
-                <a:latin typeface="Microsoft YaHei"/>
-              </a:defRPr>
-            </a:pPr>
-            <a:r>
-              <a:t>Q &amp; A</a:t>
-            </a:r>
-          </a:p>
-          <a:p>
-            <a:pPr algn="ctr">
-              <a:spcAft>
-                <a:spcPts val="720"/>
-              </a:spcAft>
-              <a:defRPr sz="1800" b="0">
-                <a:solidFill>
-                  <a:srgbClr val="CCCCCC"/>
-                </a:solidFill>
-                <a:latin typeface="Microsoft YaHei"/>
-              </a:defRPr>
-            </a:pPr>
-          </a:p>
-          <a:p>
-            <a:pPr algn="ctr">
-              <a:spcAft>
-                <a:spcPts val="720"/>
-              </a:spcAft>
-              <a:defRPr sz="1800" b="0">
-                <a:solidFill>
-                  <a:srgbClr val="CCCCCC"/>
-                </a:solidFill>
-                <a:latin typeface="Microsoft YaHei"/>
-              </a:defRPr>
-            </a:pPr>
-            <a:r>
-              <a:t>汇报人：圆子  MBA24级7班  |  科创青干营4期</a:t>
-            </a:r>
-          </a:p>
-          <a:p>
-            <a:pPr algn="ctr">
-              <a:spcAft>
-                <a:spcPts val="720"/>
-              </a:spcAft>
-              <a:defRPr sz="1800" b="0">
-                <a:solidFill>
-                  <a:srgbClr val="CCCCCC"/>
-                </a:solidFill>
-                <a:latin typeface="Microsoft YaHei"/>
-              </a:defRPr>
-            </a:pPr>
-            <a:r>
-              <a:t>Project 46 — Autonomous Retail Intelligence Agent Platform</a:t>
-            </a:r>
-          </a:p>
-        </p:txBody>
-      </p:sp>
-      <p:sp>
-        <p:nvSpPr>
-          <p:cNvPr id="7" name="Rectangle 6"/>
-          <p:cNvSpPr/>
-          <p:nvPr/>
-        </p:nvSpPr>
-        <p:spPr>
-          <a:xfrm>
-            <a:off x="0" y="6784848"/>
-            <a:ext cx="12191695" cy="73152"/>
-          </a:xfrm>
-          <a:prstGeom prst="rect">
-            <a:avLst/>
-          </a:prstGeom>
-          <a:solidFill>
-            <a:srgbClr val="FFD700"/>
-          </a:solidFill>
-          <a:ln>
-            <a:noFill/>
-          </a:ln>
-        </p:spPr>
-        <p:style>
-          <a:lnRef idx="1">
-            <a:schemeClr val="accent1"/>
-          </a:lnRef>
-          <a:fillRef idx="3">
-            <a:schemeClr val="accent1"/>
-          </a:fillRef>
-          <a:effectRef idx="2">
-            <a:schemeClr val="accent1"/>
-          </a:effectRef>
-          <a:fontRef idx="minor">
-            <a:schemeClr val="lt1"/>
-          </a:fontRef>
-        </p:style>
-        <p:txBody>
-          <a:bodyPr rtlCol="0" anchor="ctr"/>
-          <a:lstStyle/>
-          <a:p>
-            <a:pPr algn="ctr"/>
-          </a:p>
-        </p:txBody>
-      </p:sp>
-    </p:spTree>
-  </p:cSld>
-  <p:clrMapOvr>
-    <a:masterClrMapping/>
-  </p:clrMapOvr>
-</p:sld>
+<file path=ppt/slides/slide25.xml><?xml version='1.0' encoding='UTF-8' standalone='yes'?>
+<p:sld xmlns:a="http://schemas.openxmlformats.org/drawingml/2006/main" xmlns:p="http://schemas.openxmlformats.org/presentationml/2006/main" xmlns:r="http://schemas.openxmlformats.org/officeDocument/2006/relationships"><p:cSld><p:bg><p:bgPr><a:solidFill><a:srgbClr val="002050"/></a:solidFill><a:effectLst/></p:bgPr></p:bg><p:spTree><p:nvGrpSpPr><p:cNvPr id="1" name=""/><p:cNvGrpSpPr/><p:nvPr/></p:nvGrpSpPr><p:grpSpPr/><p:sp><p:nvSpPr><p:cNvPr id="2" name="Rectangle 1"/><p:cNvSpPr/><p:nvPr/></p:nvSpPr><p:spPr><a:xfrm><a:off x="0" y="0"/><a:ext cx="12191695" cy="73152"/></a:xfrm><a:prstGeom prst="rect"><a:avLst/></a:prstGeom><a:solidFill><a:srgbClr val="FFD700"/></a:solidFill><a:ln><a:noFill/></a:ln></p:spPr><p:style><a:lnRef idx="1"><a:schemeClr val="accent1"/></a:lnRef><a:fillRef idx="3"><a:schemeClr val="accent1"/></a:fillRef><a:effectRef idx="2"><a:schemeClr val="accent1"/></a:effectRef><a:fontRef idx="minor"><a:schemeClr val="lt1"/></a:fontRef></p:style><p:txBody><a:bodyPr rtlCol="0" anchor="ctr"/><a:lstStyle/><a:p><a:pPr algn="ctr"/></a:p></p:txBody></p:sp><p:sp><p:nvSpPr><p:cNvPr id="3" name="TextBox 2"/><p:cNvSpPr txBox="1"/><p:nvPr/></p:nvSpPr><p:spPr><a:xfrm><a:off x="914400" y="1828800"/><a:ext cx="10332720" cy="1371600"/></a:xfrm><a:prstGeom prst="rect"><a:avLst/></a:prstGeom><a:noFill/></p:spPr><p:txBody><a:bodyPr wrap="square"><a:spAutoFit/></a:bodyPr><a:lstStyle/><a:p><a:pPr algn="ctr"><a:defRPr sz="5200" b="1"><a:solidFill><a:srgbClr val="FFFFFF"/></a:solidFill><a:latin typeface="Microsoft YaHei"/></a:defRPr></a:pPr><a:r><a:t>Thank You</a:t></a:r></a:p></p:txBody></p:sp><p:sp><p:nvSpPr><p:cNvPr id="4" name="TextBox 3"/><p:cNvSpPr txBox="1"/><p:nvPr/></p:nvSpPr><p:spPr><a:xfrm><a:off x="914400" y="3200400"/><a:ext cx="10332720" cy="731520"/></a:xfrm><a:prstGeom prst="rect"><a:avLst/></a:prstGeom><a:noFill/></p:spPr><p:txBody><a:bodyPr wrap="square"><a:spAutoFit/></a:bodyPr><a:lstStyle/><a:p><a:pPr algn="ctr"><a:defRPr sz="3200" b="0"><a:solidFill><a:srgbClr val="FFD700"/></a:solidFill><a:latin typeface="Microsoft YaHei"/></a:defRPr></a:pPr><a:r><a:t>谢谢</a:t></a:r></a:p></p:txBody></p:sp><p:sp><p:nvSpPr><p:cNvPr id="5" name="Rectangle 4"/><p:cNvSpPr/><p:nvPr/></p:nvSpPr><p:spPr><a:xfrm><a:off x="4572000" y="4114800"/><a:ext cx="3017520" cy="36576"/></a:xfrm><a:prstGeom prst="rect"><a:avLst/></a:prstGeom><a:solidFill><a:srgbClr val="FFD700"/></a:solidFill><a:ln><a:noFill/></a:ln></p:spPr><p:style><a:lnRef idx="1"><a:schemeClr val="accent1"/></a:lnRef><a:fillRef idx="3"><a:schemeClr val="accent1"/></a:fillRef><a:effectRef idx="2"><a:schemeClr val="accent1"/></a:effectRef><a:fontRef idx="minor"><a:schemeClr val="lt1"/></a:fontRef></p:style><p:txBody><a:bodyPr rtlCol="0" anchor="ctr"/><a:lstStyle/><a:p><a:pPr algn="ctr"/></a:p></p:txBody></p:sp><p:sp><p:nvSpPr><p:cNvPr id="6" name="TextBox 5"/><p:cNvSpPr txBox="1"/><p:nvPr/></p:nvSpPr><p:spPr><a:xfrm><a:off x="914400" y="4572000"/><a:ext cx="10332720" cy="1371600"/></a:xfrm><a:prstGeom prst="rect"><a:avLst/></a:prstGeom><a:noFill/></p:spPr><p:txBody><a:bodyPr wrap="square"><a:spAutoFit/></a:bodyPr><a:lstStyle/><a:p><a:pPr algn="ctr"><a:spcAft><a:spcPts val="720"/></a:spcAft><a:defRPr sz="1800" b="0"><a:solidFill><a:srgbClr val="CCCCCC"/></a:solidFill><a:latin typeface="Microsoft YaHei"/></a:defRPr></a:pPr><a:r><a:t>Q &amp; A</a:t></a:r></a:p><a:p><a:pPr algn="ctr"><a:spcAft><a:spcPts val="720"/></a:spcAft><a:defRPr sz="1800" b="0"><a:solidFill><a:srgbClr val="CCCCCC"/></a:solidFill><a:latin typeface="Microsoft YaHei"/></a:defRPr></a:pPr></a:p><a:p><a:pPr algn="ctr"><a:spcAft><a:spcPts val="720"/></a:spcAft><a:defRPr sz="1800" b="0"><a:solidFill><a:srgbClr val="CCCCCC"/></a:solidFill><a:latin typeface="Microsoft YaHei"/></a:defRPr></a:pPr><a:r><a:t>汇报人：圆子  Senior Solution Engineer, Azure & AI Platform</a:t></a:r></a:p><a:p><a:pPr algn="ctr"><a:spcAft><a:spcPts val="720"/></a:spcAft><a:defRPr sz="1800" b="0"><a:solidFill><a:srgbClr val="CCCCCC"/></a:solidFill><a:latin typeface="Microsoft YaHei"/></a:defRPr></a:pPr><a:r><a:t>Project 46 — Autonomous Retail Intelligence Agent Platform</a:t></a:r></a:p></p:txBody></p:sp><p:sp><p:nvSpPr><p:cNvPr id="7" name="Rectangle 6"/><p:cNvSpPr/><p:nvPr/></p:nvSpPr><p:spPr><a:xfrm><a:off x="0" y="6784848"/><a:ext cx="12191695" cy="73152"/></a:xfrm><a:prstGeom prst="rect"><a:avLst/></a:prstGeom><a:solidFill><a:srgbClr val="FFD700"/></a:solidFill><a:ln><a:noFill/></a:ln></p:spPr><p:style><a:lnRef idx="1"><a:schemeClr val="accent1"/></a:lnRef><a:fillRef idx="3"><a:schemeClr val="accent1"/></a:fillRef><a:effectRef idx="2"><a:schemeClr val="accent1"/></a:effectRef><a:fontRef idx="minor"><a:schemeClr val="lt1"/></a:fontRef></p:style><p:txBody><a:bodyPr rtlCol="0" anchor="ctr"/><a:lstStyle/><a:p><a:pPr algn="ctr"/></a:p></p:txBody></p:sp></p:spTree></p:cSld><p:clrMapOvr><a:masterClrMapping/></p:clrMapOvr></p:sld>
 </file>
 
 <file path=ppt/slides/slide3.xml><?xml version="1.0" encoding="utf-8"?>

</xml_diff>